<commit_message>
Use neutral dataset identifiers and separate sample counts from dataset names
</commit_message>
<xml_diff>
--- a/submission/toy2box_presentation_draft.pptx
+++ b/submission/toy2box_presentation_draft.pptx
@@ -4082,7 +4082,7 @@
               </a:defRPr>
             </a:pPr>
             <a:r>
-              <a:t>• 선택 모델: VAR-20 → Mimic 499개 → BC-RNN/GMM</a:t>
+              <a:t>• 선택 모델: Dataset B → Mimic 499개 → BC-RNN/GMM</a:t>
             </a:r>
           </a:p>
           <a:p>
@@ -4565,7 +4565,7 @@
               </a:defRPr>
             </a:pPr>
             <a:r>
-              <a:t>• AUTO-100: 표준 자동 수집 100개 · idle 평균 0.70%</a:t>
+              <a:t>• Dataset A: 기준 구성 100개 · idle 평균 0.70%</a:t>
             </a:r>
           </a:p>
           <a:p>
@@ -4584,7 +4584,7 @@
               </a:defRPr>
             </a:pPr>
             <a:r>
-              <a:t>• VAR-20: 변화형 자동 수집 20개 · idle 평균 4.78%</a:t>
+              <a:t>• Dataset B: 변화형 구성 20개 · idle 평균 4.78%</a:t>
             </a:r>
           </a:p>
           <a:p>
@@ -4603,7 +4603,7 @@
               </a:defRPr>
             </a:pPr>
             <a:r>
-              <a:t>• PACE-20: idle 목표 21% 수집 20개 · 실제 평균 19.79%</a:t>
+              <a:t>• Dataset C: 분산 멈춤 구성 20개 · idle 평균 19.79%</a:t>
             </a:r>
           </a:p>
           <a:p>
@@ -4622,7 +4622,7 @@
               </a:defRPr>
             </a:pPr>
             <a:r>
-              <a:t>• 최종 모델의 원본은 VAR-20이며 PACE-20과 별도 계열</a:t>
+              <a:t>• 최종 모델의 원본은 Dataset B이며 Dataset C과 별도 계열</a:t>
             </a:r>
           </a:p>
         </p:txBody>
@@ -4816,7 +4816,7 @@
               </a:defRPr>
             </a:pPr>
             <a:r>
-              <a:t>• VAR-20 20개 → annotation 20개 → Mimic 성공 시범 499개</a:t>
+              <a:t>• Dataset B 20개 → annotation 20개 → Mimic 성공 시범 499개</a:t>
             </a:r>
           </a:p>
           <a:p>

</xml_diff>

<commit_message>
Remove unused dataset labels and document-source references from submission materials
</commit_message>
<xml_diff>
--- a/submission/toy2box_presentation_draft.pptx
+++ b/submission/toy2box_presentation_draft.pptx
@@ -4082,7 +4082,7 @@
               </a:defRPr>
             </a:pPr>
             <a:r>
-              <a:t>• 선택 모델: Dataset B → Mimic 499개 → BC-RNN/GMM</a:t>
+              <a:t>• 선택 모델: Mimic 499개 → BC-RNN/GMM</a:t>
             </a:r>
           </a:p>
           <a:p>
@@ -4481,7 +4481,7 @@
               </a:defRPr>
             </a:pPr>
             <a:r>
-              <a:t>2. 데이터 계열</a:t>
+              <a:t>2. 수집 데이터</a:t>
             </a:r>
           </a:p>
         </p:txBody>
@@ -4523,7 +4523,7 @@
               </a:defRPr>
             </a:pPr>
             <a:r>
-              <a:t>시간 표현 대신 고정 실험 이름 사용</a:t>
+              <a:t>시범 수·길이·idle 비교</a:t>
             </a:r>
           </a:p>
         </p:txBody>
@@ -4584,7 +4584,7 @@
               </a:defRPr>
             </a:pPr>
             <a:r>
-              <a:t>• Dataset B: 변화형 구성 20개 · idle 평균 4.78%</a:t>
+              <a:t>• Dataset C: 분산 멈춤 구성 20개 · idle 평균 19.79%</a:t>
             </a:r>
           </a:p>
           <a:p>
@@ -4603,26 +4603,7 @@
               </a:defRPr>
             </a:pPr>
             <a:r>
-              <a:t>• Dataset C: 분산 멈춤 구성 20개 · idle 평균 19.79%</a:t>
-            </a:r>
-          </a:p>
-          <a:p>
-            <a:pPr>
-              <a:lnSpc>
-                <a:spcPct val="115000"/>
-              </a:lnSpc>
-              <a:spcAft>
-                <a:spcPts val="1400"/>
-              </a:spcAft>
-              <a:defRPr sz="2200" b="0">
-                <a:solidFill>
-                  <a:srgbClr val="172B4D"/>
-                </a:solidFill>
-                <a:latin typeface="맑은 고딕"/>
-              </a:defRPr>
-            </a:pPr>
-            <a:r>
-              <a:t>• 최종 모델의 원본은 Dataset B이며 Dataset C과 별도 계열</a:t>
+              <a:t>• 수집 시범 통계와 학습 정책 평가 결과는 별도 지표</a:t>
             </a:r>
           </a:p>
         </p:txBody>
@@ -4816,7 +4797,7 @@
               </a:defRPr>
             </a:pPr>
             <a:r>
-              <a:t>• Dataset B 20개 → annotation 20개 → Mimic 성공 시범 499개</a:t>
+              <a:t>• annotation 20개 → Mimic 성공 시범 499개</a:t>
             </a:r>
           </a:p>
           <a:p>
@@ -5702,7 +5683,7 @@
               </a:defRPr>
             </a:pPr>
             <a:r>
-              <a:t>• 강의자료: 11/3 23:59 제출 · 11/5 발표 (LMS 변경 확인)</a:t>
+              <a:t>• 평가 명령어·가중치 경로·실행 환경 확인</a:t>
             </a:r>
           </a:p>
         </p:txBody>

</xml_diff>